<commit_message>
Mario and Zelda: our own exercises (a chunk level maker and moving platforms; keys and locked doors)
Co-Authored-By: Claude Opus 5.5 <noreply@anthropic.com>
Claude-Session: https://claude.ai/code/session_012sjsUQBbC7zon57rWHoo9d
</commit_message>
<xml_diff>
--- a/slides/08 The Legend of Zelda.pptx
+++ b/slides/08 The Legend of Zelda.pptx
@@ -3001,7 +3001,12 @@
           <a:lstStyle/>
           <a:p>
             <a:r>
-              <a:t>Exercise: hearts, pots to lift, pots to throw.</a:t>
+              <a:t>Exercise: keys dropped by enemies, and locked doors they open.</a:t>
+            </a:r>
+          </a:p>
+          <a:p>
+            <a:r>
+              <a:t>It joins the two ideas of the day: the key drop is an event, the locked look is data.</a:t>
             </a:r>
           </a:p>
           <a:p>
@@ -22146,7 +22151,7 @@
                   <a:schemeClr val="accent5"/>
                 </a:solidFill>
               </a:rPr>
-              <a:t>Extending Zelda</a:t>
+              <a:t>Keys and Locked Doors</a:t>
             </a:r>
             <a:endParaRPr>
               <a:solidFill>
@@ -22208,7 +22213,7 @@
             </a:pPr>
             <a:r>
               <a:rPr lang="en"/>
-              <a:t>Enemies sometimes drop a heart that heals one whole heart</a:t>
+              <a:t>Some enemies drop a key when they die: use an event</a:t>
             </a:r>
             <a:endParaRPr/>
           </a:p>
@@ -22225,7 +22230,7 @@
             </a:pPr>
             <a:r>
               <a:rPr lang="en"/>
-              <a:t>The player lifts pots (the animations are in the sheet), and carries them</a:t>
+              <a:t>A locked state for doorways, in door_layouts.xml</a:t>
             </a:r>
             <a:endParaRPr/>
           </a:p>
@@ -22242,7 +22247,7 @@
             </a:pPr>
             <a:r>
               <a:rPr lang="en"/>
-              <a:t>Thrown pots damage enemies, and break on walls, enemies or after four tiles</a:t>
+              <a:t>A key opens a locked door for good; show the keys next to the hearts</a:t>
             </a:r>
             <a:endParaRPr/>
           </a:p>

</xml_diff>